<commit_message>
content(fifty-states): wreckmatch 2026-06-03T05 UTC
</commit_message>
<xml_diff>
--- a/public/blog/presentations/semi-truck-accident-in-burlington-vermont-what-to-do-2026.pptx
+++ b/public/blog/presentations/semi-truck-accident-in-burlington-vermont-what-to-do-2026.pptx
@@ -585,7 +585,7 @@
           <a:lstStyle/>
           <a:p>
             <a:r>
-              <a:t>Is WreckMatch a law firm? — No. WreckMatch LLC is a legal referral service — not a law firm. We connect injured people with participating attorneys who handle car, truck, and catastrophic injury cases in Vermont. How fast is the callback? — Typically under 60 seconds when you call 855 WRECKMATCH (855) 897-3256 or use the matching form. What if I cannot afford a lawyer? — Participating attorneys usually work on contingency — no upfront fee for representation; fees are agreed in writing if they recover compensation for you. Where is the local help hub? — Burlington car accident help · National what-to-do guide</a:t>
+              <a:t>Is WreckMatch a law firm? — No. WreckMatch LLC is a legal referral service — not a law firm. We connect injured people with participating attorneys who handle truck and catastrophic injury cases in Vermont. How fast is the callback? — Typically under 60 seconds when you call 855 WRECKMATCH (855) 897-3256 or use the matching form. What if I cannot afford a lawyer? — Participating attorneys usually work on contingency — no upfront fee for representation; fees are agreed in writing if they recover compensation for you. Where is the local help hub? — Burlington car accident help · National truck crash guide</a:t>
             </a:r>
           </a:p>
           <a:p/>
@@ -4662,7 +4662,7 @@
               </a:defRPr>
             </a:pPr>
             <a:r>
-              <a:t>Truck Accidents · Vermont · 2026-05-31</a:t>
+              <a:t>Truck Accidents · Vermont · 2026-06-03</a:t>
             </a:r>
           </a:p>
         </p:txBody>
@@ -4819,7 +4819,7 @@
               </a:defRPr>
             </a:pPr>
             <a:r>
-              <a:t>A: No. WreckMatch LLC is a legal referral service — not a law firm. We connect injured people with participating attorneys who handle car, truck, and catastrophic injury cases in Vermont.</a:t>
+              <a:t>A: No. WreckMatch LLC is a legal referral service — not a law firm. We connect injured people with participating attorneys who handle truck and catastrophic injury cases in Vermont.</a:t>
             </a:r>
           </a:p>
           <a:p>
@@ -5223,7 +5223,7 @@
               </a:defRPr>
             </a:pPr>
             <a:r>
-              <a:t>A: Nothing up front. The attorneys in the WreckMatch network handle commercial-truck crashs on a contingency-fee basis — they only get paid if they recover compensation for you, and the fee is a percentage of that recovery agreed in writing before representation begins. The initial consultation is free, and there is no obligation to hire the attorney after the call. WreckMatch LLC itself is a legal r</a:t>
+              <a:t>A: Nothing up front. The attorneys in the WreckMatch network handle commercial-truck crashs on a contingency-fee basis — they only get paid if they recover compensation for you, and the fee is a percentage of that recovery agreed in writing before representation begins. The initial consultation is free, and there is no obligation to hire the attorney after the call. WreckMatch LLC is a legal referral</a:t>
             </a:r>
           </a:p>
           <a:p>

</xml_diff>